<commit_message>
Finished up Metrica Province
</commit_message>
<xml_diff>
--- a/storyboards/GW2 Heros Journey - wf.pptx
+++ b/storyboards/GW2 Heros Journey - wf.pptx
@@ -290,7 +290,7 @@
           <a:p>
             <a:fld id="{E908CF19-BBB9-45F0-B426-1C49897CD9DC}" type="datetimeFigureOut">
               <a:rPr lang="en-US" smtClean="0"/>
-              <a:t>8/14/2025</a:t>
+              <a:t>8/15/2025</a:t>
             </a:fld>
             <a:endParaRPr lang="en-US" dirty="0"/>
           </a:p>
@@ -488,7 +488,7 @@
           <a:p>
             <a:fld id="{E908CF19-BBB9-45F0-B426-1C49897CD9DC}" type="datetimeFigureOut">
               <a:rPr lang="en-US" smtClean="0"/>
-              <a:t>8/14/2025</a:t>
+              <a:t>8/15/2025</a:t>
             </a:fld>
             <a:endParaRPr lang="en-US" dirty="0"/>
           </a:p>
@@ -696,7 +696,7 @@
           <a:p>
             <a:fld id="{E908CF19-BBB9-45F0-B426-1C49897CD9DC}" type="datetimeFigureOut">
               <a:rPr lang="en-US" smtClean="0"/>
-              <a:t>8/14/2025</a:t>
+              <a:t>8/15/2025</a:t>
             </a:fld>
             <a:endParaRPr lang="en-US" dirty="0"/>
           </a:p>
@@ -894,7 +894,7 @@
           <a:p>
             <a:fld id="{E908CF19-BBB9-45F0-B426-1C49897CD9DC}" type="datetimeFigureOut">
               <a:rPr lang="en-US" smtClean="0"/>
-              <a:t>8/14/2025</a:t>
+              <a:t>8/15/2025</a:t>
             </a:fld>
             <a:endParaRPr lang="en-US" dirty="0"/>
           </a:p>
@@ -1169,7 +1169,7 @@
           <a:p>
             <a:fld id="{E908CF19-BBB9-45F0-B426-1C49897CD9DC}" type="datetimeFigureOut">
               <a:rPr lang="en-US" smtClean="0"/>
-              <a:t>8/14/2025</a:t>
+              <a:t>8/15/2025</a:t>
             </a:fld>
             <a:endParaRPr lang="en-US" dirty="0"/>
           </a:p>
@@ -1434,7 +1434,7 @@
           <a:p>
             <a:fld id="{E908CF19-BBB9-45F0-B426-1C49897CD9DC}" type="datetimeFigureOut">
               <a:rPr lang="en-US" smtClean="0"/>
-              <a:t>8/14/2025</a:t>
+              <a:t>8/15/2025</a:t>
             </a:fld>
             <a:endParaRPr lang="en-US" dirty="0"/>
           </a:p>
@@ -1846,7 +1846,7 @@
           <a:p>
             <a:fld id="{E908CF19-BBB9-45F0-B426-1C49897CD9DC}" type="datetimeFigureOut">
               <a:rPr lang="en-US" smtClean="0"/>
-              <a:t>8/14/2025</a:t>
+              <a:t>8/15/2025</a:t>
             </a:fld>
             <a:endParaRPr lang="en-US" dirty="0"/>
           </a:p>
@@ -1987,7 +1987,7 @@
           <a:p>
             <a:fld id="{E908CF19-BBB9-45F0-B426-1C49897CD9DC}" type="datetimeFigureOut">
               <a:rPr lang="en-US" smtClean="0"/>
-              <a:t>8/14/2025</a:t>
+              <a:t>8/15/2025</a:t>
             </a:fld>
             <a:endParaRPr lang="en-US" dirty="0"/>
           </a:p>
@@ -2100,7 +2100,7 @@
           <a:p>
             <a:fld id="{E908CF19-BBB9-45F0-B426-1C49897CD9DC}" type="datetimeFigureOut">
               <a:rPr lang="en-US" smtClean="0"/>
-              <a:t>8/14/2025</a:t>
+              <a:t>8/15/2025</a:t>
             </a:fld>
             <a:endParaRPr lang="en-US" dirty="0"/>
           </a:p>
@@ -2411,7 +2411,7 @@
           <a:p>
             <a:fld id="{E908CF19-BBB9-45F0-B426-1C49897CD9DC}" type="datetimeFigureOut">
               <a:rPr lang="en-US" smtClean="0"/>
-              <a:t>8/14/2025</a:t>
+              <a:t>8/15/2025</a:t>
             </a:fld>
             <a:endParaRPr lang="en-US" dirty="0"/>
           </a:p>
@@ -2699,7 +2699,7 @@
           <a:p>
             <a:fld id="{E908CF19-BBB9-45F0-B426-1C49897CD9DC}" type="datetimeFigureOut">
               <a:rPr lang="en-US" smtClean="0"/>
-              <a:t>8/14/2025</a:t>
+              <a:t>8/15/2025</a:t>
             </a:fld>
             <a:endParaRPr lang="en-US" dirty="0"/>
           </a:p>
@@ -2940,7 +2940,7 @@
           <a:p>
             <a:fld id="{E908CF19-BBB9-45F0-B426-1C49897CD9DC}" type="datetimeFigureOut">
               <a:rPr lang="en-US" smtClean="0"/>
-              <a:t>8/14/2025</a:t>
+              <a:t>8/15/2025</a:t>
             </a:fld>
             <a:endParaRPr lang="en-US" dirty="0"/>
           </a:p>

</xml_diff>